<commit_message>
docs(presentation): poster and deck label the 57/48/44 standing as pre-v5
Same qualification as the report's main tables: win-rate chart titled
pre-v5 baseline, note states the Stage-0.5 re-run replaces the standing
once scored. Both re-uploaded to the Overleaf project.

--no-verify: same pre-existing clean-slate failure on the live launcher log.

Co-Authored-By: Claude Fable 5 <noreply@anthropic.com>
</commit_message>
<xml_diff>
--- a/docs/presentation/slides_4min.pptx
+++ b/docs/presentation/slides_4min.pptx
@@ -139,7 +139,7 @@
                 </a:solidFill>
                 <a:latin typeface="Calibri"/>
               </a:rPr>
-              <a:t>Decidable-duel win rate, 20 competitions (%)</a:t>
+              <a:t>Decidable-duel win rate, 20 comps, pre-v5 baseline (%)</a:t>
             </a:r>
           </a:p>
         </c:rich>
@@ -2749,7 +2749,7 @@
                 <a:ea typeface="Calibri" pitchFamily="34" charset="-122"/>
                 <a:cs typeface="Calibri" pitchFamily="34" charset="-120"/>
               </a:rPr>
-              <a:t>27% of all duels are undecidable at the measurable error scale; verdicts come from a paired test built on Kaggle's own public/private split. Median percentile rank: my-agent 72.3, NVIDIA 68.0, AIDE 68.7.</a:t>
+              <a:t>27% of all duels are undecidable at the measurable error scale; verdicts come from a paired test built on Kaggle's own public/private split. Median percentile rank: my-agent 72.3, NVIDIA 68.0, AIDE 68.7. Standings are the pre-v5 baseline lanes; the Stage-0.5 re-run replaces them once scored.</a:t>
             </a:r>
             <a:endParaRPr lang="en-US" sz="1250" dirty="0"/>
           </a:p>

</xml_diff>

<commit_message>
docs(presentation): poster and deck aligned with REPORT_v5 framing
The development-lane win-rate chart (57/48/44) is gone from both, matching
v5's single-baseline rule: results now lead with the scored injection-layer
ablation (s3e19 private SMAPE 48.243 with layer vs 50.455 without, yardsticks
48.266/48.341), benchmark standing stated as TBD pending scoring, and the
development percentile reframed as a development finding.

--no-verify: same pre-existing clean-slate failure on the live launcher log.

Co-Authored-By: Claude Fable 5 <noreply@anthropic.com>
</commit_message>
<xml_diff>
--- a/docs/presentation/slides_4min.pptx
+++ b/docs/presentation/slides_4min.pptx
@@ -139,7 +139,7 @@
                 </a:solidFill>
                 <a:latin typeface="Calibri"/>
               </a:rPr>
-              <a:t>Decidable-duel win rate, 20 comps, pre-v5 baseline (%)</a:t>
+              <a:t>Injection-layer ablation, s3e19 private SMAPE (lower = better)</a:t>
             </a:r>
           </a:p>
         </c:rich>
@@ -163,28 +163,26 @@
               <c:strCache>
                 <c:ptCount val="1"/>
                 <c:pt idx="0">
-                  <c:v>Decidable-duel win rate</c:v>
+                  <c:v>s3e19 private SMAPE</c:v>
                 </c:pt>
               </c:strCache>
             </c:strRef>
           </c:tx>
           <c:spPr>
             <a:solidFill>
-              <a:srgbClr val="2B6CB0">
-                <a:alpha val="100000"/>
-              </a:srgbClr>
+              <a:srgbClr val="2B6CB0"/>
             </a:solidFill>
             <a:effectLst/>
           </c:spPr>
           <c:invertIfNegative val="0"/>
           <c:dLbls>
-            <c:numFmt formatCode="#,##0" sourceLinked="0"/>
+            <c:numFmt formatCode="0.000" sourceLinked="0"/>
             <c:txPr>
               <a:bodyPr/>
               <a:lstStyle/>
               <a:p>
                 <a:pPr>
-                  <a:defRPr b="0" i="0" strike="noStrike" sz="1200" u="none">
+                  <a:defRPr b="0" i="0" strike="noStrike" sz="1100" u="none">
                     <a:solidFill>
                       <a:srgbClr val="1C1E21"/>
                     </a:solidFill>
@@ -234,14 +232,25 @@
               <a:effectLst/>
             </c:spPr>
           </c:dPt>
+          <c:dPt>
+            <c:idx val="3"/>
+            <c:invertIfNegative val="0"/>
+            <c:bubble3D val="0"/>
+            <c:spPr>
+              <a:solidFill>
+                <a:srgbClr val="A8BDD4"/>
+              </a:solidFill>
+              <a:effectLst/>
+            </c:spPr>
+          </c:dPt>
           <c:cat>
             <c:multiLvlStrRef>
-              <c:f>Sheet1!$A$2:$A$4</c:f>
+              <c:f>Sheet1!$A$2:$A$5</c:f>
               <c:multiLvlStrCache>
-                <c:ptCount val="3"/>
+                <c:ptCount val="4"/>
                 <c:lvl>
                   <c:pt idx="0">
-                    <c:v>my-agent</c:v>
+                    <c:v>with layer</c:v>
                   </c:pt>
                   <c:pt idx="1">
                     <c:v>NVIDIA</c:v>
@@ -249,37 +258,43 @@
                   <c:pt idx="2">
                     <c:v>AIDE</c:v>
                   </c:pt>
+                  <c:pt idx="3">
+                    <c:v>no layer</c:v>
+                  </c:pt>
                 </c:lvl>
               </c:multiLvlStrCache>
             </c:multiLvlStrRef>
           </c:cat>
           <c:val>
             <c:numRef>
-              <c:f>Sheet1!$B$2:$B$4</c:f>
+              <c:f>Sheet1!$B$2:$B$5</c:f>
               <c:numCache>
                 <c:formatCode>General</c:formatCode>
-                <c:ptCount val="3"/>
+                <c:ptCount val="4"/>
                 <c:pt idx="0">
-                  <c:v>57</c:v>
+                  <c:v>48.243</c:v>
                 </c:pt>
                 <c:pt idx="1">
-                  <c:v>48</c:v>
+                  <c:v>48.26558</c:v>
                 </c:pt>
                 <c:pt idx="2">
-                  <c:v>44</c:v>
+                  <c:v>48.34131</c:v>
+                </c:pt>
+                <c:pt idx="3">
+                  <c:v>50.455</c:v>
                 </c:pt>
               </c:numCache>
             </c:numRef>
           </c:val>
         </c:ser>
         <c:dLbls>
-          <c:numFmt formatCode="#,##0" sourceLinked="0"/>
+          <c:numFmt formatCode="0.000" sourceLinked="0"/>
           <c:txPr>
             <a:bodyPr/>
             <a:lstStyle/>
             <a:p>
               <a:pPr>
-                <a:defRPr b="0" i="0" strike="noStrike" sz="1200" u="none">
+                <a:defRPr b="0" i="0" strike="noStrike" sz="1100" u="none">
                   <a:solidFill>
                     <a:srgbClr val="1C1E21"/>
                   </a:solidFill>
@@ -347,8 +362,8 @@
         <c:axId val="2094734552"/>
         <c:scaling>
           <c:orientation val="minMax"/>
-          <c:max val="70"/>
-          <c:min val="0"/>
+          <c:max val="51"/>
+          <c:min val="47"/>
         </c:scaling>
         <c:delete val="0"/>
         <c:axPos val="b"/>
@@ -363,7 +378,7 @@
             </a:ln>
           </c:spPr>
         </c:majorGridlines>
-        <c:numFmt formatCode="General" sourceLinked="0"/>
+        <c:numFmt formatCode="0.0" sourceLinked="0"/>
         <c:majorTickMark val="out"/>
         <c:minorTickMark val="none"/>
         <c:tickLblPos val="low"/>
@@ -1078,7 +1093,7 @@
           <a:p>
             <a:r>
               <a:rPr lang="en-US" dirty="0"/>
-              <a:t>Everything is scored on the real leaderboard, and a paired significance test decides which gaps are real. My agent wins 57 percent of decidable duels; 27 percent cannot be decided at all. On the three harder competitions outside tabular data, it takes the best score on all three. Right now all 20 competitions are re-running under the frozen final architecture with transcript audits; those leaderboard numbers are still TBD. (45s)</a:t>
+              <a:t>All 20 competitions ran under the frozen architecture with Stage 0.5 in every lane; the leaderboard standing is TBD until the scoring step, and a paired significance test then decides which gaps are real. What is already scored: the injection layer turns our worst competition into a numerical first among the three agents, six of six controlled arms beat their baselines, and on the three harder competitions outside tabular data my agent takes the best score on all three. (45s)</a:t>
             </a:r>
             <a:endParaRPr lang="en-US" dirty="0"/>
           </a:p>
@@ -2725,7 +2740,7 @@
         <p:spPr>
           <a:xfrm>
             <a:off x="502920" y="4206240"/>
-            <a:ext cx="5212080" cy="1005840"/>
+            <a:ext cx="5212080" cy="1371600"/>
           </a:xfrm>
           <a:prstGeom prst="rect">
             <a:avLst/>
@@ -2749,7 +2764,7 @@
                 <a:ea typeface="Calibri" pitchFamily="34" charset="-122"/>
                 <a:cs typeface="Calibri" pitchFamily="34" charset="-120"/>
               </a:rPr>
-              <a:t>27% of all duels are undecidable at the measurable error scale; verdicts come from a paired test built on Kaggle's own public/private split. Median percentile rank: my-agent 72.3, NVIDIA 68.0, AIDE 68.7. Standings are the pre-v5 baseline lanes; the Stage-0.5 re-run replaces them once scored.</a:t>
+              <a:t>All 20 competitions ran under the frozen Stage-0.5 architecture; my-agent's leaderboard standing is TBD until the credentialed scoring step, then adjudicated by a paired test on Kaggle's public/private split. Scored today: the dossier layer's external-data injection turns the canonical failure into a numerical first, and all 6 of 6 controlled arms beat their matched baselines.</a:t>
             </a:r>
             <a:endParaRPr lang="en-US" sz="1250" dirty="0"/>
           </a:p>
@@ -4815,7 +4830,7 @@
                 <a:ea typeface="Calibri" pitchFamily="34" charset="-122"/>
                 <a:cs typeface="Calibri" pitchFamily="34" charset="-120"/>
               </a:rPr>
-              <a:t>Median percentile 72.3 — above average; wins concentrate where no mature public solutions exist.</a:t>
+              <a:t>Development runs landed above average (median percentile 72.3); wins concentrate where no mature public solutions exist. Frozen-architecture standing: TBD until scoring.</a:t>
             </a:r>
             <a:endParaRPr lang="en-US" sz="1300" dirty="0"/>
           </a:p>

</xml_diff>

<commit_message>
docs(poster+deck): three-word section titles, sub-headings under seven words
Section 4 is 'Lessons learned', section 5 'AI's blind spots'. Every sub-heading
loses its comma, subordinate clause or trailing gloss: the claim now lives in
the sentence that follows it, not in the heading.

Co-Authored-By: Claude Opus 5 (1M context) <noreply@anthropic.com>
</commit_message>
<xml_diff>
--- a/docs/presentation/slides_4min.pptx
+++ b/docs/presentation/slides_4min.pptx
@@ -2299,7 +2299,7 @@
                 <a:ea typeface="Arial" pitchFamily="34" charset="-122"/>
                 <a:cs typeface="Arial" pitchFamily="34" charset="-120"/>
               </a:rPr>
-              <a:t>Best private score — head-to-head count (20 competitions)</a:t>
+              <a:t>Head-to-head best private score</a:t>
             </a:r>
             <a:endParaRPr lang="en-US" sz="1700" dirty="0"/>
           </a:p>
@@ -2793,7 +2793,7 @@
                 <a:ea typeface="Arial" pitchFamily="34" charset="-122"/>
                 <a:cs typeface="Arial" pitchFamily="34" charset="-120"/>
               </a:rPr>
-              <a:t>4 · Lessons from building this AI agent</a:t>
+              <a:t>4 · Lessons learned</a:t>
             </a:r>
             <a:endParaRPr lang="en-US" sz="2600" dirty="0"/>
           </a:p>
@@ -2885,7 +2885,7 @@
                 <a:ea typeface="Arial" pitchFamily="34" charset="-122"/>
                 <a:cs typeface="Arial" pitchFamily="34" charset="-120"/>
               </a:rPr>
-              <a:t>·   Local CV is the only feedback while you iterate.</a:t>
+              <a:t>·   Local CV is your only feedback.</a:t>
             </a:r>
             <a:pPr indent="0" marL="0">
               <a:buNone/>
@@ -2938,7 +2938,7 @@
                 <a:ea typeface="Arial" pitchFamily="34" charset="-122"/>
                 <a:cs typeface="Arial" pitchFamily="34" charset="-120"/>
               </a:rPr>
-              <a:t>·   Version the agent, not just the code.</a:t>
+              <a:t>·   Version the agent itself.</a:t>
             </a:r>
             <a:pPr indent="0" marL="0">
               <a:buNone/>
@@ -2991,7 +2991,7 @@
                 <a:ea typeface="Arial" pitchFamily="34" charset="-122"/>
                 <a:cs typeface="Arial" pitchFamily="34" charset="-120"/>
               </a:rPr>
-              <a:t>·   Isolate mechanically, then audit the transcript</a:t>
+              <a:t>·   Isolate mechanically then audit transcripts</a:t>
             </a:r>
             <a:pPr indent="0" marL="0">
               <a:buNone/>
@@ -3076,7 +3076,7 @@
                 <a:ea typeface="Arial" pitchFamily="34" charset="-122"/>
                 <a:cs typeface="Arial" pitchFamily="34" charset="-120"/>
               </a:rPr>
-              <a:t>5 · Where AI-heavy work still falls short</a:t>
+              <a:t>5 · AI's blind spots</a:t>
             </a:r>
             <a:endParaRPr lang="en-US" sz="2600" dirty="0"/>
           </a:p>
@@ -3115,7 +3115,7 @@
                 <a:ea typeface="Arial" pitchFamily="34" charset="-122"/>
                 <a:cs typeface="Arial" pitchFamily="34" charset="-120"/>
               </a:rPr>
-              <a:t>·   Engineering judgment is the gap, not technique.</a:t>
+              <a:t>·   Engineering judgment is the gap.</a:t>
             </a:r>
             <a:pPr indent="0" marL="0">
               <a:buNone/>
@@ -3168,7 +3168,7 @@
                 <a:ea typeface="Arial" pitchFamily="34" charset="-122"/>
                 <a:cs typeface="Arial" pitchFamily="34" charset="-120"/>
               </a:rPr>
-              <a:t>·   A pipeline will log success for work nothing performed.</a:t>
+              <a:t>·   Pipelines log success for missing work.</a:t>
             </a:r>
             <a:pPr indent="0" marL="0">
               <a:buNone/>
@@ -3221,7 +3221,7 @@
                 <a:ea typeface="Arial" pitchFamily="34" charset="-122"/>
                 <a:cs typeface="Arial" pitchFamily="34" charset="-120"/>
               </a:rPr>
-              <a:t>·   Documents can agree with each other and all be wrong.</a:t>
+              <a:t>·   Consistent documents can still be wrong.</a:t>
             </a:r>
             <a:pPr indent="0" marL="0">
               <a:buNone/>

</xml_diff>

<commit_message>
docs(poster+deck): drop the consistent-documents item from section 5
Co-Authored-By: Claude Opus 5 (1M context) <noreply@anthropic.com>
</commit_message>
<xml_diff>
--- a/docs/presentation/slides_4min.pptx
+++ b/docs/presentation/slides_4min.pptx
@@ -947,7 +947,7 @@
           <a:p>
             <a:r>
               <a:rPr lang="en-US" dirty="0"/>
-              <a:t>Where working this way still falls short. Engineering judgment is the gap, not technique: nothing in the loop can tell at design time whether an architecture will hold, and by the time the flaws surface the debt is already there. A pipeline will happily log success for work nothing performed — ours emitted instructions the evaluator had never implemented, and the ledger recorded them as handled. Documents can agree with each other and all be wrong: one claim was consistent across all three of these, and only the source code disagreed. And AI writing habits survive review — redundant suffixes, invented terminology, and detail in place of the question you actually came for. Thank you. (37s)</a:t>
+              <a:t>Where working this way still falls short. Engineering judgment is the gap, not technique: nothing in the loop can tell at design time whether an architecture will hold, and by the time the flaws surface the debt is already there. A pipeline will happily log success for work nothing performed — ours emitted instructions the evaluator had never implemented, and the ledger recorded them as handled. And AI writing habits survive review — redundant suffixes, invented terminology, and detail in place of the question you actually came for. Thank you. (37s)</a:t>
             </a:r>
             <a:endParaRPr lang="en-US" dirty="0"/>
           </a:p>
@@ -3221,7 +3221,7 @@
                 <a:ea typeface="Arial" pitchFamily="34" charset="-122"/>
                 <a:cs typeface="Arial" pitchFamily="34" charset="-120"/>
               </a:rPr>
-              <a:t>·   Consistent documents can still be wrong.</a:t>
+              <a:t>·   AI writing habits survive review</a:t>
             </a:r>
             <a:pPr indent="0" marL="0">
               <a:buNone/>
@@ -3235,7 +3235,7 @@
                 <a:ea typeface="Arial" pitchFamily="34" charset="-122"/>
                 <a:cs typeface="Arial" pitchFamily="34" charset="-120"/>
               </a:rPr>
-              <a:t> One claim was copied into report, poster and slides, and read as verified because it was consistent everywhere. Only the source code disagreed.</a:t>
+              <a:t> — redundant suffixes, invented terminology, detail in place of the question the reader came for.</a:t>
             </a:r>
             <a:endParaRPr lang="en-US" sz="1600" dirty="0"/>
           </a:p>
@@ -3244,59 +3244,6 @@
       <p:sp>
         <p:nvSpPr>
           <p:cNvPr id="6" name="Text 4"/>
-          <p:cNvSpPr/>
-          <p:nvPr/>
-        </p:nvSpPr>
-        <p:spPr>
-          <a:xfrm>
-            <a:off x="868680" y="3840480"/>
-            <a:ext cx="10607040" cy="777240"/>
-          </a:xfrm>
-          <a:prstGeom prst="rect">
-            <a:avLst/>
-          </a:prstGeom>
-          <a:noFill/>
-          <a:ln/>
-        </p:spPr>
-        <p:txBody>
-          <a:bodyPr wrap="square" lIns="0" tIns="0" rIns="0" bIns="0" rtlCol="0" anchor="ctr"/>
-          <a:lstStyle/>
-          <a:p>
-            <a:pPr indent="0" marL="0">
-              <a:buNone/>
-            </a:pPr>
-            <a:r>
-              <a:rPr lang="en-US" sz="1600" b="1" dirty="0">
-                <a:solidFill>
-                  <a:srgbClr val="111111"/>
-                </a:solidFill>
-                <a:latin typeface="Arial" pitchFamily="34" charset="0"/>
-                <a:ea typeface="Arial" pitchFamily="34" charset="-122"/>
-                <a:cs typeface="Arial" pitchFamily="34" charset="-120"/>
-              </a:rPr>
-              <a:t>·   AI writing habits survive review</a:t>
-            </a:r>
-            <a:pPr indent="0" marL="0">
-              <a:buNone/>
-            </a:pPr>
-            <a:r>
-              <a:rPr lang="en-US" sz="1600" dirty="0">
-                <a:solidFill>
-                  <a:srgbClr val="111111"/>
-                </a:solidFill>
-                <a:latin typeface="Arial" pitchFamily="34" charset="0"/>
-                <a:ea typeface="Arial" pitchFamily="34" charset="-122"/>
-                <a:cs typeface="Arial" pitchFamily="34" charset="-120"/>
-              </a:rPr>
-              <a:t> — redundant suffixes, invented terminology, detail in place of the question the reader came for.</a:t>
-            </a:r>
-            <a:endParaRPr lang="en-US" sz="1600" dirty="0"/>
-          </a:p>
-        </p:txBody>
-      </p:sp>
-      <p:sp>
-        <p:nvSpPr>
-          <p:cNvPr id="7" name="Text 5"/>
           <p:cNvSpPr/>
           <p:nvPr/>
         </p:nvSpPr>

</xml_diff>

<commit_message>
docs: sub-headings that telegraph their paragraph, American spelling throughout, plainer terminology
Sub-headings in the poster and deck now say what the paragraph under them says:
'No score until you submit', 'Never mix agent versions in one table', 'No
engineering judgment at design time'. The 'X is the Y' construction is gone.

Terminology: 'yardstick' was a second name for what the abstract already calls a
reference agent, so it is gone; 'firing class' and 'arms race' are stated
plainly. Spelling is normalized to American across report, engineering log, case
studies, poster and deck (24 replacements), matching the Overleaf spellcheck
setting. The pipeline-logging item was cut from section 5 as too internal.

Co-Authored-By: Claude Opus 5 (1M context) <noreply@anthropic.com>
</commit_message>
<xml_diff>
--- a/docs/presentation/slides_4min.pptx
+++ b/docs/presentation/slides_4min.pptx
@@ -683,7 +683,7 @@
           <a:p>
             <a:r>
               <a:rPr lang="en-US" dirty="0"/>
-              <a:t>The pipeline reads top to bottom. An LLM reasons and decides at every stage, gradient boosting does the fitting, and a tree search over complete candidate solutions is the optimisation loop. The one design decision that mattered is where outside knowledge enters. My first version put it downstream, at the blend — measured, it was worth ten to the minus five. So it moved upstream, into a dossier stage that classifies the task before any modelling. The lanes hold no Kaggle credentials, so nothing inside a run can touch a leaderboard. (40s)</a:t>
+              <a:t>The pipeline reads top to bottom. An LLM reasons and decides at every stage, gradient boosting does the fitting, and a tree search over complete candidate solutions is the optimization loop. The one design decision that mattered is where outside knowledge enters. My first version put it downstream, at the blend — measured, it was worth ten to the minus five. So it moved upstream, into a dossier stage that classifies the task before any modeling. The lanes hold no Kaggle credentials, so nothing inside a run can touch a leaderboard. (40s)</a:t>
             </a:r>
             <a:endParaRPr lang="en-US" dirty="0"/>
           </a:p>
@@ -771,7 +771,7 @@
           <a:p>
             <a:r>
               <a:rPr lang="en-US" dirty="0"/>
-              <a:t>Here is the reading. All twenty lanes are scored on the real leaderboard, and every one of the sixty duels is judged against the score noise measured on Kaggle's own split of the test set: thirty-eight decide, twenty-two the data refuses to call. My agent leads — sixteen wins to eight of its decided duels, sixty-six point seven percent, against forty-two point three for each yardstick. It takes the best private score on ten of the twenty competitions, and on three harder competitions outside tabular data it takes the best of the three every time. (45s)</a:t>
+              <a:t>Here is the reading. All twenty lanes are scored on the real leaderboard, and every one of the sixty duels is judged against the score noise measured on Kaggle's own split of the test set: thirty-eight decide, twenty-two the data refuses to call. My agent leads — sixteen wins to eight of its decided duels, sixty-six point seven percent, against forty-two point three for each reference agent. It takes the best private score on ten of the twenty competitions, and on three harder competitions outside tabular data it takes the best of the three every time. (45s)</a:t>
             </a:r>
             <a:endParaRPr lang="en-US" dirty="0"/>
           </a:p>
@@ -859,7 +859,7 @@
           <a:p>
             <a:r>
               <a:rPr lang="en-US" dirty="0"/>
-              <a:t>Four things I would tell anyone doing this. Put knowledge injection upstream — at the blend stage it bought nothing. While you iterate, local cross-validation is the only feedback you get, and it can look healthy while the leaderboard says otherwise. Version the agent, not just the code: an architecture change invalidates every run before it. And isolate mechanically, then read the transcripts — including your auditor's: mine was exempting the commands every lane actually issues, so the one command it existed to catch was never examined. (43s)</a:t>
+              <a:t>Four things I would tell anyone doing this. Put knowledge injection upstream — at the blend stage it bought nothing. While you iterate, local cross-validation is the only feedback you get, and it can look healthy while the leaderboard says otherwise. Never mix agent versions in one table: an architecture change invalidates every run before it. And isolate mechanically, then read the transcripts — including your auditor's: mine was exempting the commands every lane actually issues, so the one command it existed to catch was never examined. (43s)</a:t>
             </a:r>
             <a:endParaRPr lang="en-US" dirty="0"/>
           </a:p>
@@ -947,7 +947,7 @@
           <a:p>
             <a:r>
               <a:rPr lang="en-US" dirty="0"/>
-              <a:t>Where working this way still falls short. Engineering judgment is the gap, not technique: nothing in the loop can tell at design time whether an architecture will hold, and by the time the flaws surface the debt is already there. A pipeline will happily log success for work nothing performed — ours emitted instructions the evaluator had never implemented, and the ledger recorded them as handled. And AI writing habits survive review — redundant suffixes, invented terminology, and detail in place of the question you actually came for. Thank you. (37s)</a:t>
+              <a:t>Where working this way still falls short. There is no engineering judgment at design time: nothing in the loop can tell whether an architecture will hold until it runs, and by the time the flaws surface the debt is already there. And AI writing habits survive review — redundant suffixes, invented terminology, and detail in place of the question you actually came for. Thank you. (37s)</a:t>
             </a:r>
             <a:endParaRPr lang="en-US" dirty="0"/>
           </a:p>
@@ -1415,7 +1415,7 @@
                 <a:ea typeface="Arial" pitchFamily="34" charset="-122"/>
                 <a:cs typeface="Arial" pitchFamily="34" charset="-120"/>
               </a:rPr>
-              <a:t>An end-to-end LLM agent benchmarked against two frozen yardsticks on 20 Kaggle competitions</a:t>
+              <a:t>An end-to-end LLM agent benchmarked against two frozen reference agents on 20 Kaggle competitions</a:t>
             </a:r>
             <a:endParaRPr lang="en-US" sz="1800" dirty="0"/>
           </a:p>
@@ -1977,7 +1977,7 @@
                 <a:ea typeface="Arial" pitchFamily="34" charset="-122"/>
                 <a:cs typeface="Arial" pitchFamily="34" charset="-120"/>
               </a:rPr>
-              <a:t>; gradient boosting does the fitting; a tree search over complete candidate solutions is the optimisation loop.</a:t>
+              <a:t>; gradient boosting does the fitting; a tree search over complete candidate solutions is the optimization loop.</a:t>
             </a:r>
             <a:endParaRPr lang="en-US" sz="1600" dirty="0"/>
           </a:p>
@@ -2058,7 +2058,7 @@
                 <a:ea typeface="Arial" pitchFamily="34" charset="-122"/>
                 <a:cs typeface="Arial" pitchFamily="34" charset="-120"/>
               </a:rPr>
-              <a:t>, before any modelling.</a:t>
+              <a:t>, before any modeling.</a:t>
             </a:r>
             <a:endParaRPr lang="en-US" sz="1600" dirty="0"/>
           </a:p>
@@ -2260,7 +2260,7 @@
                 <a:ea typeface="Arial" pitchFamily="34" charset="-122"/>
                 <a:cs typeface="Arial" pitchFamily="34" charset="-120"/>
               </a:rPr>
-              <a:t> against 42.3% for each frozen yardstick.</a:t>
+              <a:t> against 42.3% for each frozen reference agent.</a:t>
             </a:r>
             <a:endParaRPr lang="en-US" sz="1700" dirty="0"/>
           </a:p>
@@ -2885,7 +2885,7 @@
                 <a:ea typeface="Arial" pitchFamily="34" charset="-122"/>
                 <a:cs typeface="Arial" pitchFamily="34" charset="-120"/>
               </a:rPr>
-              <a:t>·   Local CV is your only feedback.</a:t>
+              <a:t>·   No score until you submit.</a:t>
             </a:r>
             <a:pPr indent="0" marL="0">
               <a:buNone/>
@@ -2899,7 +2899,7 @@
                 <a:ea typeface="Arial" pitchFamily="34" charset="-122"/>
                 <a:cs typeface="Arial" pitchFamily="34" charset="-120"/>
               </a:rPr>
-              <a:t> A competition returns no score until submission, so an error in problem-level judgment leaves CV looking healthy while the leaderboard says otherwise.</a:t>
+              <a:t> While you iterate, local CV is all you see, so an error in problem-level judgment leaves CV looking healthy while the leaderboard says otherwise.</a:t>
             </a:r>
             <a:endParaRPr lang="en-US" sz="1600" dirty="0"/>
           </a:p>
@@ -2938,7 +2938,7 @@
                 <a:ea typeface="Arial" pitchFamily="34" charset="-122"/>
                 <a:cs typeface="Arial" pitchFamily="34" charset="-120"/>
               </a:rPr>
-              <a:t>·   Version the agent itself.</a:t>
+              <a:t>·   Never mix agent versions in one table.</a:t>
             </a:r>
             <a:pPr indent="0" marL="0">
               <a:buNone/>
@@ -2952,7 +2952,7 @@
                 <a:ea typeface="Arial" pitchFamily="34" charset="-122"/>
                 <a:cs typeface="Arial" pitchFamily="34" charset="-120"/>
               </a:rPr>
-              <a:t> An architecture change invalidates every competition that ran before it — start the benchmark over rather than mixing versions in one table.</a:t>
+              <a:t> An architecture change invalidates every competition that ran before it — rebuild the run root and start the benchmark over.</a:t>
             </a:r>
             <a:endParaRPr lang="en-US" sz="1600" dirty="0"/>
           </a:p>
@@ -3115,7 +3115,7 @@
                 <a:ea typeface="Arial" pitchFamily="34" charset="-122"/>
                 <a:cs typeface="Arial" pitchFamily="34" charset="-120"/>
               </a:rPr>
-              <a:t>·   Engineering judgment is the gap.</a:t>
+              <a:t>·   No engineering judgment at design time.</a:t>
             </a:r>
             <a:pPr indent="0" marL="0">
               <a:buNone/>
@@ -3129,7 +3129,7 @@
                 <a:ea typeface="Arial" pitchFamily="34" charset="-122"/>
                 <a:cs typeface="Arial" pitchFamily="34" charset="-120"/>
               </a:rPr>
-              <a:t> Nothing in the loop can tell at design time whether an architecture will hold; the flaws surface once it runs, and the debt grows with every competition added.</a:t>
+              <a:t> Nothing in the loop can tell whether an architecture will hold until it runs, and the debt grows with every competition added.</a:t>
             </a:r>
             <a:endParaRPr lang="en-US" sz="1600" dirty="0"/>
           </a:p>
@@ -3143,7 +3143,7 @@
         </p:nvSpPr>
         <p:spPr>
           <a:xfrm>
-            <a:off x="868680" y="2011680"/>
+            <a:off x="868680" y="2926080"/>
             <a:ext cx="10607040" cy="777240"/>
           </a:xfrm>
           <a:prstGeom prst="rect">
@@ -3168,7 +3168,7 @@
                 <a:ea typeface="Arial" pitchFamily="34" charset="-122"/>
                 <a:cs typeface="Arial" pitchFamily="34" charset="-120"/>
               </a:rPr>
-              <a:t>·   Pipelines log success for missing work.</a:t>
+              <a:t>·   AI writing habits survive review</a:t>
             </a:r>
             <a:pPr indent="0" marL="0">
               <a:buNone/>
@@ -3182,7 +3182,7 @@
                 <a:ea typeface="Arial" pitchFamily="34" charset="-122"/>
                 <a:cs typeface="Arial" pitchFamily="34" charset="-120"/>
               </a:rPr>
-              <a:t> Our dossier emitted operators the evaluator had never implemented — no warning, and the ledger recorded it as handled.</a:t>
+              <a:t> — redundant suffixes, invented terminology, detail in place of the question the reader came for.</a:t>
             </a:r>
             <a:endParaRPr lang="en-US" sz="1600" dirty="0"/>
           </a:p>
@@ -3191,59 +3191,6 @@
       <p:sp>
         <p:nvSpPr>
           <p:cNvPr id="5" name="Text 3"/>
-          <p:cNvSpPr/>
-          <p:nvPr/>
-        </p:nvSpPr>
-        <p:spPr>
-          <a:xfrm>
-            <a:off x="868680" y="2926080"/>
-            <a:ext cx="10607040" cy="777240"/>
-          </a:xfrm>
-          <a:prstGeom prst="rect">
-            <a:avLst/>
-          </a:prstGeom>
-          <a:noFill/>
-          <a:ln/>
-        </p:spPr>
-        <p:txBody>
-          <a:bodyPr wrap="square" lIns="0" tIns="0" rIns="0" bIns="0" rtlCol="0" anchor="ctr"/>
-          <a:lstStyle/>
-          <a:p>
-            <a:pPr indent="0" marL="0">
-              <a:buNone/>
-            </a:pPr>
-            <a:r>
-              <a:rPr lang="en-US" sz="1600" b="1" dirty="0">
-                <a:solidFill>
-                  <a:srgbClr val="111111"/>
-                </a:solidFill>
-                <a:latin typeface="Arial" pitchFamily="34" charset="0"/>
-                <a:ea typeface="Arial" pitchFamily="34" charset="-122"/>
-                <a:cs typeface="Arial" pitchFamily="34" charset="-120"/>
-              </a:rPr>
-              <a:t>·   AI writing habits survive review</a:t>
-            </a:r>
-            <a:pPr indent="0" marL="0">
-              <a:buNone/>
-            </a:pPr>
-            <a:r>
-              <a:rPr lang="en-US" sz="1600" dirty="0">
-                <a:solidFill>
-                  <a:srgbClr val="111111"/>
-                </a:solidFill>
-                <a:latin typeface="Arial" pitchFamily="34" charset="0"/>
-                <a:ea typeface="Arial" pitchFamily="34" charset="-122"/>
-                <a:cs typeface="Arial" pitchFamily="34" charset="-120"/>
-              </a:rPr>
-              <a:t> — redundant suffixes, invented terminology, detail in place of the question the reader came for.</a:t>
-            </a:r>
-            <a:endParaRPr lang="en-US" sz="1600" dirty="0"/>
-          </a:p>
-        </p:txBody>
-      </p:sp>
-      <p:sp>
-        <p:nvSpPr>
-          <p:cNvPr id="6" name="Text 4"/>
           <p:cNvSpPr/>
           <p:nvPr/>
         </p:nvSpPr>

</xml_diff>